<commit_message>
Add dedicated editable templates for all 40 retrieval activities
</commit_message>
<xml_diff>
--- a/retrieval-brain-dump-template.pptx
+++ b/retrieval-brain-dump-template.pptx
@@ -2,13 +2,13 @@
 <file path=ppt/presentation.xml><?xml version="1.0" encoding="utf-8"?>
 <p:presentation xmlns:p="http://schemas.openxmlformats.org/presentationml/2006/main">
   <p:sldMasterIdLst>
-    <p:sldMasterId xmlns:r="http://schemas.openxmlformats.org/officeDocument/2006/relationships" id="2147483648" r:id="Rddb6f3cfb90b4264"/>
+    <p:sldMasterId xmlns:r="http://schemas.openxmlformats.org/officeDocument/2006/relationships" id="2147483648" r:id="R51db55db5b544b87"/>
   </p:sldMasterIdLst>
   <p:notesMasterIdLst>
-    <p:notesMasterId xmlns:r="http://schemas.openxmlformats.org/officeDocument/2006/relationships" r:id="R111723cb49c14786"/>
+    <p:notesMasterId xmlns:r="http://schemas.openxmlformats.org/officeDocument/2006/relationships" r:id="R0f5a5a442a704ed9"/>
   </p:notesMasterIdLst>
   <p:sldIdLst>
-    <p:sldId xmlns:r="http://schemas.openxmlformats.org/officeDocument/2006/relationships" id="256" r:id="Raf3ce8b446d8421c"/>
+    <p:sldId xmlns:r="http://schemas.openxmlformats.org/officeDocument/2006/relationships" id="256" r:id="Rce3da3fffbe34c56"/>
   </p:sldIdLst>
   <p:sldSz cx="12192000" cy="6858000"/>
   <p:notesSz cx="6858000" cy="9144000"/>
@@ -442,62 +442,7 @@
           <a:lstStyle xmlns:a="http://schemas.openxmlformats.org/drawingml/2006/main"/>
           <a:p xmlns:a="http://schemas.openxmlformats.org/drawingml/2006/main">
             <a:r>
-              <a:t>Teacher setup: Replace bracketed text before teaching. All text and shapes are editable. Duplicate the slide for answers or another prompt. For card activities, separate prompt and answer sides before printing.</a:t>
-            </a:r>
-          </a:p>
-          <a:p xmlns:a="http://schemas.openxmlformats.org/drawingml/2006/main">
-            <a:r>
-              <a:t/>
-            </a:r>
-          </a:p>
-          <a:p xmlns:a="http://schemas.openxmlformats.org/drawingml/2006/main">
-            <a:r>
-              <a:t>Materials: Paper or mini whiteboards</a:t>
-            </a:r>
-          </a:p>
-          <a:p xmlns:a="http://schemas.openxmlformats.org/drawingml/2006/main">
-            <a:r>
-              <a:t>Suggested time including feedback: 5 minutes.</a:t>
-            </a:r>
-          </a:p>
-          <a:p xmlns:a="http://schemas.openxmlformats.org/drawingml/2006/main">
-            <a:r>
-              <a:t/>
-            </a:r>
-          </a:p>
-          <a:p xmlns:a="http://schemas.openxmlformats.org/drawingml/2006/main">
-            <a:r>
-              <a:t>1. Set a boundary: Name a previously taught topic and close notes.</a:t>
-            </a:r>
-          </a:p>
-          <a:p xmlns:a="http://schemas.openxmlformats.org/drawingml/2006/main">
-            <a:r>
-              <a:t>2. Recall independently: Everyone writes or sketches what they remember for two minutes.</a:t>
-            </a:r>
-          </a:p>
-          <a:p xmlns:a="http://schemas.openxmlformats.org/drawingml/2006/main">
-            <a:r>
-              <a:t>3. Organise the recall: Group related ideas and mark uncertain details.</a:t>
-            </a:r>
-          </a:p>
-          <a:p xmlns:a="http://schemas.openxmlformats.org/drawingml/2006/main">
-            <a:r>
-              <a:t>4. Check and improve: Compare with a trusted reference; correct errors in another colour.</a:t>
-            </a:r>
-          </a:p>
-          <a:p xmlns:a="http://schemas.openxmlformats.org/drawingml/2006/main">
-            <a:r>
-              <a:t/>
-            </a:r>
-          </a:p>
-          <a:p xmlns:a="http://schemas.openxmlformats.org/drawingml/2006/main">
-            <a:r>
-              <a:t>Check: Sample explanations as well as keywords. Ask students to retrieve a corrected idea again later.</a:t>
-            </a:r>
-          </a:p>
-          <a:p xmlns:a="http://schemas.openxmlformats.org/drawingml/2006/main">
-            <a:r>
-              <a:t>Adapt: Use broad headings if a blank page feels overwhelming; allow spoken recording or labelled sketches.</a:t>
+              <a:t>Replace bracketed text with your own taught prompts and checked answers. All labels and response areas are editable. Give everyone an independent attempt before revealing answers. Duplicate the slide for answers or another prompt. For cards, print the prompt and answer on opposite sides or fold them to keep answers hidden.</a:t>
             </a:r>
           </a:p>
         </p:txBody>
@@ -544,7 +489,7 @@
           <p:cNvPr id="4" name="Accent rule">
             <a:extLst xmlns:a="http://schemas.openxmlformats.org/drawingml/2006/main">
               <a:ext uri="{FF2B5EF4-FFF2-40B4-BE49-F238E27FC236}">
-                <a16:creationId xmlns:a16="http://schemas.microsoft.com/office/drawing/2014/main" id="{F1C421B9-2701-4A5C-A3A0-198090727923}"/>
+                <a16:creationId xmlns:a16="http://schemas.microsoft.com/office/drawing/2014/main" id="{62BB8939-F269-4890-B6C6-53CCECBC52EF}"/>
               </a:ext>
             </a:extLst>
           </p:cNvPr>
@@ -575,7 +520,7 @@
           <p:cNvPr id="2" name="Title">
             <a:extLst xmlns:a="http://schemas.openxmlformats.org/drawingml/2006/main">
               <a:ext uri="{FF2B5EF4-FFF2-40B4-BE49-F238E27FC236}">
-                <a16:creationId xmlns:a16="http://schemas.microsoft.com/office/drawing/2014/main" id="{54C4E6E3-F346-488A-BFA4-6C6109719D80}"/>
+                <a16:creationId xmlns:a16="http://schemas.microsoft.com/office/drawing/2014/main" id="{E80473EE-5F6A-4124-99DB-3167758B5840}"/>
               </a:ext>
             </a:extLst>
           </p:cNvPr>
@@ -722,7 +667,7 @@
           <p:cNvPr id="3" name="Subtitle">
             <a:extLst xmlns:a="http://schemas.openxmlformats.org/drawingml/2006/main">
               <a:ext uri="{FF2B5EF4-FFF2-40B4-BE49-F238E27FC236}">
-                <a16:creationId xmlns:a16="http://schemas.microsoft.com/office/drawing/2014/main" id="{25C6F8FC-7829-4F7F-949F-168AD2EE5736}"/>
+                <a16:creationId xmlns:a16="http://schemas.microsoft.com/office/drawing/2014/main" id="{D019DD90-8D31-4484-AF45-A4F36C28B8CD}"/>
               </a:ext>
             </a:extLst>
           </p:cNvPr>
@@ -886,7 +831,7 @@
           <p:cNvPr id="3" name="Accent rule">
             <a:extLst xmlns:a="http://schemas.openxmlformats.org/drawingml/2006/main">
               <a:ext uri="{FF2B5EF4-FFF2-40B4-BE49-F238E27FC236}">
-                <a16:creationId xmlns:a16="http://schemas.microsoft.com/office/drawing/2014/main" id="{E727AF49-C4D4-4C42-916D-EBBE5CB616AE}"/>
+                <a16:creationId xmlns:a16="http://schemas.microsoft.com/office/drawing/2014/main" id="{CFD4EEAC-8C9A-4008-838A-F94EC1A9AFCE}"/>
               </a:ext>
             </a:extLst>
           </p:cNvPr>
@@ -917,7 +862,7 @@
           <p:cNvPr id="2" name="Section title">
             <a:extLst xmlns:a="http://schemas.openxmlformats.org/drawingml/2006/main">
               <a:ext uri="{FF2B5EF4-FFF2-40B4-BE49-F238E27FC236}">
-                <a16:creationId xmlns:a16="http://schemas.microsoft.com/office/drawing/2014/main" id="{145651D3-979F-412B-88D8-D96382D98EF7}"/>
+                <a16:creationId xmlns:a16="http://schemas.microsoft.com/office/drawing/2014/main" id="{1B079742-1908-4C1A-89D2-F2D06C646695}"/>
               </a:ext>
             </a:extLst>
           </p:cNvPr>
@@ -1081,7 +1026,7 @@
           <p:cNvPr id="4" name="Accent rule">
             <a:extLst xmlns:a="http://schemas.openxmlformats.org/drawingml/2006/main">
               <a:ext uri="{FF2B5EF4-FFF2-40B4-BE49-F238E27FC236}">
-                <a16:creationId xmlns:a16="http://schemas.microsoft.com/office/drawing/2014/main" id="{85DF76C0-95E3-4D3C-8560-4E2C82DD6584}"/>
+                <a16:creationId xmlns:a16="http://schemas.microsoft.com/office/drawing/2014/main" id="{B7BA21F0-2A50-401D-93E9-D3B6DFFF8FC9}"/>
               </a:ext>
             </a:extLst>
           </p:cNvPr>
@@ -1112,7 +1057,7 @@
           <p:cNvPr id="2" name="Title">
             <a:extLst xmlns:a="http://schemas.openxmlformats.org/drawingml/2006/main">
               <a:ext uri="{FF2B5EF4-FFF2-40B4-BE49-F238E27FC236}">
-                <a16:creationId xmlns:a16="http://schemas.microsoft.com/office/drawing/2014/main" id="{D9CDB5F3-43A5-4270-87B3-5A655F9A73E5}"/>
+                <a16:creationId xmlns:a16="http://schemas.microsoft.com/office/drawing/2014/main" id="{89BEBF1E-E12B-421E-B35B-0AC041B1811D}"/>
               </a:ext>
             </a:extLst>
           </p:cNvPr>
@@ -1259,7 +1204,7 @@
           <p:cNvPr id="3" name="Body">
             <a:extLst xmlns:a="http://schemas.openxmlformats.org/drawingml/2006/main">
               <a:ext uri="{FF2B5EF4-FFF2-40B4-BE49-F238E27FC236}">
-                <a16:creationId xmlns:a16="http://schemas.microsoft.com/office/drawing/2014/main" id="{B3C66EA9-B7D5-4FC5-A73F-E342BD9DCE1F}"/>
+                <a16:creationId xmlns:a16="http://schemas.microsoft.com/office/drawing/2014/main" id="{71B78F0D-0991-4E6B-83EB-73A2D7AC160F}"/>
               </a:ext>
             </a:extLst>
           </p:cNvPr>
@@ -1423,7 +1368,7 @@
           <p:cNvPr id="5" name="Accent rule">
             <a:extLst xmlns:a="http://schemas.openxmlformats.org/drawingml/2006/main">
               <a:ext uri="{FF2B5EF4-FFF2-40B4-BE49-F238E27FC236}">
-                <a16:creationId xmlns:a16="http://schemas.microsoft.com/office/drawing/2014/main" id="{C2BED7CE-1CA2-4CEA-ADC5-9DA29FAEB9DE}"/>
+                <a16:creationId xmlns:a16="http://schemas.microsoft.com/office/drawing/2014/main" id="{56C2DBF9-59DF-4AF3-92B9-AB65DA484EFE}"/>
               </a:ext>
             </a:extLst>
           </p:cNvPr>
@@ -1454,7 +1399,7 @@
           <p:cNvPr id="2" name="Title">
             <a:extLst xmlns:a="http://schemas.openxmlformats.org/drawingml/2006/main">
               <a:ext uri="{FF2B5EF4-FFF2-40B4-BE49-F238E27FC236}">
-                <a16:creationId xmlns:a16="http://schemas.microsoft.com/office/drawing/2014/main" id="{0F9681FD-1D6D-4026-950F-6DCFBA2E3ED2}"/>
+                <a16:creationId xmlns:a16="http://schemas.microsoft.com/office/drawing/2014/main" id="{32EA94A3-D95C-40DF-BFD6-56BC7D99ECA0}"/>
               </a:ext>
             </a:extLst>
           </p:cNvPr>
@@ -1601,7 +1546,7 @@
           <p:cNvPr id="3" name="Left column">
             <a:extLst xmlns:a="http://schemas.openxmlformats.org/drawingml/2006/main">
               <a:ext uri="{FF2B5EF4-FFF2-40B4-BE49-F238E27FC236}">
-                <a16:creationId xmlns:a16="http://schemas.microsoft.com/office/drawing/2014/main" id="{24684C84-7879-4671-9942-A28F2A5A6FC2}"/>
+                <a16:creationId xmlns:a16="http://schemas.microsoft.com/office/drawing/2014/main" id="{7BC13FC1-4546-480F-894E-12B36E7FDE57}"/>
               </a:ext>
             </a:extLst>
           </p:cNvPr>
@@ -1748,7 +1693,7 @@
           <p:cNvPr id="4" name="Right column">
             <a:extLst xmlns:a="http://schemas.openxmlformats.org/drawingml/2006/main">
               <a:ext uri="{FF2B5EF4-FFF2-40B4-BE49-F238E27FC236}">
-                <a16:creationId xmlns:a16="http://schemas.microsoft.com/office/drawing/2014/main" id="{64AA538A-2CEE-4D05-96C6-F4928CED08BC}"/>
+                <a16:creationId xmlns:a16="http://schemas.microsoft.com/office/drawing/2014/main" id="{2541CDA6-5C2D-45E9-B94A-643732E06CBC}"/>
               </a:ext>
             </a:extLst>
           </p:cNvPr>
@@ -1912,7 +1857,7 @@
           <p:cNvPr id="4" name="Accent rule">
             <a:extLst xmlns:a="http://schemas.openxmlformats.org/drawingml/2006/main">
               <a:ext uri="{FF2B5EF4-FFF2-40B4-BE49-F238E27FC236}">
-                <a16:creationId xmlns:a16="http://schemas.microsoft.com/office/drawing/2014/main" id="{44133AA0-494C-4B4B-A3DB-6EF58AA83C5E}"/>
+                <a16:creationId xmlns:a16="http://schemas.microsoft.com/office/drawing/2014/main" id="{F8EE16AE-DFFB-43C0-A85D-FCD963D89615}"/>
               </a:ext>
             </a:extLst>
           </p:cNvPr>
@@ -1943,7 +1888,7 @@
           <p:cNvPr id="2" name="Title">
             <a:extLst xmlns:a="http://schemas.openxmlformats.org/drawingml/2006/main">
               <a:ext uri="{FF2B5EF4-FFF2-40B4-BE49-F238E27FC236}">
-                <a16:creationId xmlns:a16="http://schemas.microsoft.com/office/drawing/2014/main" id="{EDC145FB-4911-431E-ABB7-726A85AEFFAB}"/>
+                <a16:creationId xmlns:a16="http://schemas.microsoft.com/office/drawing/2014/main" id="{7B7C801D-A1EC-4881-A993-8F69223DE312}"/>
               </a:ext>
             </a:extLst>
           </p:cNvPr>
@@ -2090,7 +2035,7 @@
           <p:cNvPr id="3" name="Left column">
             <a:extLst xmlns:a="http://schemas.openxmlformats.org/drawingml/2006/main">
               <a:ext uri="{FF2B5EF4-FFF2-40B4-BE49-F238E27FC236}">
-                <a16:creationId xmlns:a16="http://schemas.microsoft.com/office/drawing/2014/main" id="{812F40D8-B925-4C19-A3CD-4B54EA972023}"/>
+                <a16:creationId xmlns:a16="http://schemas.microsoft.com/office/drawing/2014/main" id="{1C4B39A5-10AE-4D36-A784-A10ED2A575FF}"/>
               </a:ext>
             </a:extLst>
           </p:cNvPr>
@@ -2275,12 +2220,12 @@
   </p:cSld>
   <p:clrMap bg1="lt1" tx1="dk1" bg2="lt2" tx2="dk2" accent1="accent1" accent2="accent2" accent3="accent3" accent4="accent4" accent5="accent5" accent6="accent6" hlink="hlink" folHlink="folHlink"/>
   <p:sldLayoutIdLst>
-    <p:sldLayoutId xmlns:r="http://schemas.openxmlformats.org/officeDocument/2006/relationships" id="2147483649" r:id="Redb4e5b5e6f2432a"/>
-    <p:sldLayoutId xmlns:r="http://schemas.openxmlformats.org/officeDocument/2006/relationships" id="2147483650" r:id="Rd72e0b2455d347b3"/>
-    <p:sldLayoutId xmlns:r="http://schemas.openxmlformats.org/officeDocument/2006/relationships" id="2147483651" r:id="Re1c64a2866e04520"/>
-    <p:sldLayoutId xmlns:r="http://schemas.openxmlformats.org/officeDocument/2006/relationships" id="2147483652" r:id="R239a025c0fb04297"/>
-    <p:sldLayoutId xmlns:r="http://schemas.openxmlformats.org/officeDocument/2006/relationships" id="2147483653" r:id="R3c1df101ee0e4301"/>
-    <p:sldLayoutId xmlns:r="http://schemas.openxmlformats.org/officeDocument/2006/relationships" id="2147483654" r:id="R620d483691994c0c"/>
+    <p:sldLayoutId xmlns:r="http://schemas.openxmlformats.org/officeDocument/2006/relationships" id="2147483649" r:id="Rcacb934a36204009"/>
+    <p:sldLayoutId xmlns:r="http://schemas.openxmlformats.org/officeDocument/2006/relationships" id="2147483650" r:id="R2f22998381f34725"/>
+    <p:sldLayoutId xmlns:r="http://schemas.openxmlformats.org/officeDocument/2006/relationships" id="2147483651" r:id="R221a78ff50234db9"/>
+    <p:sldLayoutId xmlns:r="http://schemas.openxmlformats.org/officeDocument/2006/relationships" id="2147483652" r:id="R02974ee7e03d4a54"/>
+    <p:sldLayoutId xmlns:r="http://schemas.openxmlformats.org/officeDocument/2006/relationships" id="2147483653" r:id="R6765d02a601f4ad1"/>
+    <p:sldLayoutId xmlns:r="http://schemas.openxmlformats.org/officeDocument/2006/relationships" id="2147483654" r:id="Ra7d0e156d7fa4bd7"/>
   </p:sldLayoutIdLst>
   <p:txStyles>
     <p:titleStyle>
@@ -2831,7 +2776,7 @@
           <p:cNvPr id="15" name="">
             <a:extLst xmlns:a="http://schemas.openxmlformats.org/drawingml/2006/main">
               <a:ext uri="{FF2B5EF4-FFF2-40B4-BE49-F238E27FC236}">
-                <a16:creationId xmlns:a16="http://schemas.microsoft.com/office/drawing/2014/main" id="{A847B1AF-89C5-4A67-B943-D3CB70A8114E}"/>
+                <a16:creationId xmlns:a16="http://schemas.microsoft.com/office/drawing/2014/main" id="{E764946A-DA14-48C3-B03E-57A4B5010355}"/>
               </a:ext>
             </a:extLst>
           </p:cNvPr>
@@ -2888,7 +2833,7 @@
           <p:cNvPr id="2" name="">
             <a:extLst xmlns:a="http://schemas.openxmlformats.org/drawingml/2006/main">
               <a:ext uri="{FF2B5EF4-FFF2-40B4-BE49-F238E27FC236}">
-                <a16:creationId xmlns:a16="http://schemas.microsoft.com/office/drawing/2014/main" id="{523D886D-A8B1-4F93-AED2-A0597733CF8B}"/>
+                <a16:creationId xmlns:a16="http://schemas.microsoft.com/office/drawing/2014/main" id="{B45E26FD-4AFA-4A7C-9C1F-F5C4D0A7520D}"/>
               </a:ext>
             </a:extLst>
           </p:cNvPr>
@@ -2945,7 +2890,7 @@
           <p:cNvPr id="3" name="">
             <a:extLst xmlns:a="http://schemas.openxmlformats.org/drawingml/2006/main">
               <a:ext uri="{FF2B5EF4-FFF2-40B4-BE49-F238E27FC236}">
-                <a16:creationId xmlns:a16="http://schemas.microsoft.com/office/drawing/2014/main" id="{E81DCD6A-F5F3-4629-9B15-475BE4740BC0}"/>
+                <a16:creationId xmlns:a16="http://schemas.microsoft.com/office/drawing/2014/main" id="{60C8C7D7-5A8C-4744-A3B9-BAA54EA4BAF6}"/>
               </a:ext>
             </a:extLst>
           </p:cNvPr>
@@ -2975,7 +2920,7 @@
           <p:cNvPr id="4" name="">
             <a:extLst xmlns:a="http://schemas.openxmlformats.org/drawingml/2006/main">
               <a:ext uri="{FF2B5EF4-FFF2-40B4-BE49-F238E27FC236}">
-                <a16:creationId xmlns:a16="http://schemas.microsoft.com/office/drawing/2014/main" id="{55EE22FC-BD2C-4E95-B3DC-AEDA609A39B9}"/>
+                <a16:creationId xmlns:a16="http://schemas.microsoft.com/office/drawing/2014/main" id="{8D0E57C1-F34F-47DF-9152-4D670DDF4ADA}"/>
               </a:ext>
             </a:extLst>
           </p:cNvPr>
@@ -3032,7 +2977,7 @@
           <p:cNvPr id="5" name="">
             <a:extLst xmlns:a="http://schemas.openxmlformats.org/drawingml/2006/main">
               <a:ext uri="{FF2B5EF4-FFF2-40B4-BE49-F238E27FC236}">
-                <a16:creationId xmlns:a16="http://schemas.microsoft.com/office/drawing/2014/main" id="{BC427EFF-E1B3-4864-B732-143E1ADD5E51}"/>
+                <a16:creationId xmlns:a16="http://schemas.microsoft.com/office/drawing/2014/main" id="{FB00D9B2-EE5C-46BB-A160-7DA216B35930}"/>
               </a:ext>
             </a:extLst>
           </p:cNvPr>
@@ -3089,7 +3034,7 @@
           <p:cNvPr id="6" name="">
             <a:extLst xmlns:a="http://schemas.openxmlformats.org/drawingml/2006/main">
               <a:ext uri="{FF2B5EF4-FFF2-40B4-BE49-F238E27FC236}">
-                <a16:creationId xmlns:a16="http://schemas.microsoft.com/office/drawing/2014/main" id="{8F5C1B4D-A4A6-4FD4-8DA4-145E233D1477}"/>
+                <a16:creationId xmlns:a16="http://schemas.microsoft.com/office/drawing/2014/main" id="{D08280C7-EAC5-4509-99A4-9701E473BA78}"/>
               </a:ext>
             </a:extLst>
           </p:cNvPr>
@@ -3121,7 +3066,7 @@
           <p:cNvPr id="7" name="">
             <a:extLst xmlns:a="http://schemas.openxmlformats.org/drawingml/2006/main">
               <a:ext uri="{FF2B5EF4-FFF2-40B4-BE49-F238E27FC236}">
-                <a16:creationId xmlns:a16="http://schemas.microsoft.com/office/drawing/2014/main" id="{48AAA147-C814-4756-9A85-0233778F70A3}"/>
+                <a16:creationId xmlns:a16="http://schemas.microsoft.com/office/drawing/2014/main" id="{75387886-5D0C-43EA-828A-9DA69BAFF42A}"/>
               </a:ext>
             </a:extLst>
           </p:cNvPr>
@@ -3151,7 +3096,7 @@
           <p:cNvPr id="8" name="">
             <a:extLst xmlns:a="http://schemas.openxmlformats.org/drawingml/2006/main">
               <a:ext uri="{FF2B5EF4-FFF2-40B4-BE49-F238E27FC236}">
-                <a16:creationId xmlns:a16="http://schemas.microsoft.com/office/drawing/2014/main" id="{88CC3B34-EF73-4ED5-AC1C-C4940BFD695F}"/>
+                <a16:creationId xmlns:a16="http://schemas.microsoft.com/office/drawing/2014/main" id="{45E0C976-4BFD-491A-A830-839B46DA4FEF}"/>
               </a:ext>
             </a:extLst>
           </p:cNvPr>
@@ -3208,7 +3153,7 @@
           <p:cNvPr id="9" name="">
             <a:extLst xmlns:a="http://schemas.openxmlformats.org/drawingml/2006/main">
               <a:ext uri="{FF2B5EF4-FFF2-40B4-BE49-F238E27FC236}">
-                <a16:creationId xmlns:a16="http://schemas.microsoft.com/office/drawing/2014/main" id="{8FC3A03E-C751-41C6-BF59-0727B89D1C39}"/>
+                <a16:creationId xmlns:a16="http://schemas.microsoft.com/office/drawing/2014/main" id="{1F896C6B-F9D4-4EEC-8304-BB6D263FCCC7}"/>
               </a:ext>
             </a:extLst>
           </p:cNvPr>
@@ -3265,7 +3210,7 @@
           <p:cNvPr id="10" name="">
             <a:extLst xmlns:a="http://schemas.openxmlformats.org/drawingml/2006/main">
               <a:ext uri="{FF2B5EF4-FFF2-40B4-BE49-F238E27FC236}">
-                <a16:creationId xmlns:a16="http://schemas.microsoft.com/office/drawing/2014/main" id="{13780980-90CB-4628-9410-19C3F711D5BC}"/>
+                <a16:creationId xmlns:a16="http://schemas.microsoft.com/office/drawing/2014/main" id="{2AC9FAA4-F13F-4BED-984B-B0C0AE8F9E9E}"/>
               </a:ext>
             </a:extLst>
           </p:cNvPr>
@@ -3322,7 +3267,7 @@
           <p:cNvPr id="11" name="">
             <a:extLst xmlns:a="http://schemas.openxmlformats.org/drawingml/2006/main">
               <a:ext uri="{FF2B5EF4-FFF2-40B4-BE49-F238E27FC236}">
-                <a16:creationId xmlns:a16="http://schemas.microsoft.com/office/drawing/2014/main" id="{623A9693-961A-4348-BFFC-EAB37A2C23F3}"/>
+                <a16:creationId xmlns:a16="http://schemas.microsoft.com/office/drawing/2014/main" id="{1AB041F6-06B3-4791-BC32-EC58BFCF0269}"/>
               </a:ext>
             </a:extLst>
           </p:cNvPr>
@@ -3379,7 +3324,7 @@
           <p:cNvPr id="12" name="">
             <a:extLst xmlns:a="http://schemas.openxmlformats.org/drawingml/2006/main">
               <a:ext uri="{FF2B5EF4-FFF2-40B4-BE49-F238E27FC236}">
-                <a16:creationId xmlns:a16="http://schemas.microsoft.com/office/drawing/2014/main" id="{B298753E-C154-4E25-B1A7-D8820E827B64}"/>
+                <a16:creationId xmlns:a16="http://schemas.microsoft.com/office/drawing/2014/main" id="{5E81F238-43A6-4A1B-89EF-BA1D40F84621}"/>
               </a:ext>
             </a:extLst>
           </p:cNvPr>
@@ -3409,7 +3354,7 @@
           <p:cNvPr id="13" name="">
             <a:extLst xmlns:a="http://schemas.openxmlformats.org/drawingml/2006/main">
               <a:ext uri="{FF2B5EF4-FFF2-40B4-BE49-F238E27FC236}">
-                <a16:creationId xmlns:a16="http://schemas.microsoft.com/office/drawing/2014/main" id="{D617C923-E1B3-4F02-8742-8B282ED4819B}"/>
+                <a16:creationId xmlns:a16="http://schemas.microsoft.com/office/drawing/2014/main" id="{1BA15656-5093-46E8-8166-43D590C7B577}"/>
               </a:ext>
             </a:extLst>
           </p:cNvPr>
@@ -3466,7 +3411,7 @@
           <p:cNvPr id="14" name="">
             <a:extLst xmlns:a="http://schemas.openxmlformats.org/drawingml/2006/main">
               <a:ext uri="{FF2B5EF4-FFF2-40B4-BE49-F238E27FC236}">
-                <a16:creationId xmlns:a16="http://schemas.microsoft.com/office/drawing/2014/main" id="{B4084003-8921-4AC2-A698-C2A71C6E72C2}"/>
+                <a16:creationId xmlns:a16="http://schemas.microsoft.com/office/drawing/2014/main" id="{B3A26DC4-4E2C-48E9-8429-7FC2F29C0F23}"/>
               </a:ext>
             </a:extLst>
           </p:cNvPr>
@@ -3521,7 +3466,7 @@
     </p:spTree>
     <p:extLst>
       <p:ext uri="{BB962C8B-B14F-4D97-AF65-F5344CB8AC3E}">
-        <p14:creationId xmlns:p14="http://schemas.microsoft.com/office/powerpoint/2010/main" val="987474474"/>
+        <p14:creationId xmlns:p14="http://schemas.microsoft.com/office/powerpoint/2010/main" val="1250563040"/>
       </p:ext>
     </p:extLst>
   </p:cSld>

</xml_diff>